<commit_message>
Update logo and use it as the site favicon
Co-Authored-By: Claude Sonnet 5 <noreply@anthropic.com>
</commit_message>
<xml_diff>
--- a/images/logo.pptx
+++ b/images/logo.pptx
@@ -104,7 +104,97 @@
       </a:defRPr>
     </a:lvl9pPr>
   </p:defaultTextStyle>
+  <p:extLst>
+    <p:ext uri="{EFAFB233-063F-42B5-8137-9DF3F51BA10A}">
+      <p15:sldGuideLst xmlns:p15="http://schemas.microsoft.com/office/powerpoint/2012/main"/>
+    </p:ext>
+  </p:extLst>
 </p:presentation>
+</file>
+
+<file path=ppt/revisionInfo.xml><?xml version="1.0" encoding="utf-8"?>
+<p1510:revInfo xmlns:a="http://schemas.openxmlformats.org/drawingml/2006/main" xmlns:r="http://schemas.openxmlformats.org/officeDocument/2006/relationships" xmlns:p1510="http://schemas.microsoft.com/office/powerpoint/2015/10/main">
+  <p1510:revLst>
+    <p1510:client id="{BBB88A27-FA18-41DE-9724-D9D6F25CB5C6}" v="3" dt="2026-09-22T10:36:13.151"/>
+  </p1510:revLst>
+</p1510:revInfo>
+</file>
+
+<file path=ppt/changesInfos/changesInfo1.xml><?xml version="1.0" encoding="utf-8"?>
+<pc:chgInfo xmlns:a="http://schemas.openxmlformats.org/drawingml/2006/main" xmlns:r="http://schemas.openxmlformats.org/officeDocument/2006/relationships" xmlns:ac="http://schemas.microsoft.com/office/drawing/2013/main/command" xmlns:pc="http://schemas.microsoft.com/office/powerpoint/2013/main/command">
+  <pc:docChgLst>
+    <pc:chgData name="Berkhout, J. (Joost)" userId="86ece86d-8a1a-449b-aae1-5a9ecac02076" providerId="ADAL" clId="{364D4078-C4D2-4C25-A20E-109728476AA8}"/>
+    <pc:docChg chg="undo custSel modSld">
+      <pc:chgData name="Berkhout, J. (Joost)" userId="86ece86d-8a1a-449b-aae1-5a9ecac02076" providerId="ADAL" clId="{364D4078-C4D2-4C25-A20E-109728476AA8}" dt="2026-09-22T10:36:45.680" v="10" actId="732"/>
+      <pc:docMkLst>
+        <pc:docMk/>
+      </pc:docMkLst>
+      <pc:sldChg chg="addSp modSp mod">
+        <pc:chgData name="Berkhout, J. (Joost)" userId="86ece86d-8a1a-449b-aae1-5a9ecac02076" providerId="ADAL" clId="{364D4078-C4D2-4C25-A20E-109728476AA8}" dt="2026-09-22T10:36:45.680" v="10" actId="732"/>
+        <pc:sldMkLst>
+          <pc:docMk/>
+          <pc:sldMk cId="1539186271" sldId="256"/>
+        </pc:sldMkLst>
+        <pc:spChg chg="mod">
+          <ac:chgData name="Berkhout, J. (Joost)" userId="86ece86d-8a1a-449b-aae1-5a9ecac02076" providerId="ADAL" clId="{364D4078-C4D2-4C25-A20E-109728476AA8}" dt="2026-09-22T10:34:52.237" v="0" actId="164"/>
+          <ac:spMkLst>
+            <pc:docMk/>
+            <pc:sldMk cId="1539186271" sldId="256"/>
+            <ac:spMk id="4" creationId="{D428F276-84A1-56B2-F399-873494756128}"/>
+          </ac:spMkLst>
+        </pc:spChg>
+        <pc:spChg chg="mod">
+          <ac:chgData name="Berkhout, J. (Joost)" userId="86ece86d-8a1a-449b-aae1-5a9ecac02076" providerId="ADAL" clId="{364D4078-C4D2-4C25-A20E-109728476AA8}" dt="2026-09-22T10:35:07.476" v="2" actId="1076"/>
+          <ac:spMkLst>
+            <pc:docMk/>
+            <pc:sldMk cId="1539186271" sldId="256"/>
+            <ac:spMk id="5" creationId="{B07CC5FF-DB59-C597-4D3C-F706E69D25DA}"/>
+          </ac:spMkLst>
+        </pc:spChg>
+        <pc:spChg chg="mod">
+          <ac:chgData name="Berkhout, J. (Joost)" userId="86ece86d-8a1a-449b-aae1-5a9ecac02076" providerId="ADAL" clId="{364D4078-C4D2-4C25-A20E-109728476AA8}" dt="2026-09-22T10:36:11.447" v="3"/>
+          <ac:spMkLst>
+            <pc:docMk/>
+            <pc:sldMk cId="1539186271" sldId="256"/>
+            <ac:spMk id="6" creationId="{B5E1236F-395B-7DFA-1BD5-25FD490D3850}"/>
+          </ac:spMkLst>
+        </pc:spChg>
+        <pc:spChg chg="mod">
+          <ac:chgData name="Berkhout, J. (Joost)" userId="86ece86d-8a1a-449b-aae1-5a9ecac02076" providerId="ADAL" clId="{364D4078-C4D2-4C25-A20E-109728476AA8}" dt="2026-09-22T10:36:11.447" v="3"/>
+          <ac:spMkLst>
+            <pc:docMk/>
+            <pc:sldMk cId="1539186271" sldId="256"/>
+            <ac:spMk id="7" creationId="{D744D1B5-5E9B-5016-9554-908A21E88222}"/>
+          </ac:spMkLst>
+        </pc:spChg>
+        <pc:grpChg chg="add mod">
+          <ac:chgData name="Berkhout, J. (Joost)" userId="86ece86d-8a1a-449b-aae1-5a9ecac02076" providerId="ADAL" clId="{364D4078-C4D2-4C25-A20E-109728476AA8}" dt="2026-09-22T10:34:52.237" v="0" actId="164"/>
+          <ac:grpSpMkLst>
+            <pc:docMk/>
+            <pc:sldMk cId="1539186271" sldId="256"/>
+            <ac:grpSpMk id="2" creationId="{B4F32D37-7D30-B3DC-D73D-5B1A400FB610}"/>
+          </ac:grpSpMkLst>
+        </pc:grpChg>
+        <pc:grpChg chg="add mod">
+          <ac:chgData name="Berkhout, J. (Joost)" userId="86ece86d-8a1a-449b-aae1-5a9ecac02076" providerId="ADAL" clId="{364D4078-C4D2-4C25-A20E-109728476AA8}" dt="2026-09-22T10:36:11.447" v="3"/>
+          <ac:grpSpMkLst>
+            <pc:docMk/>
+            <pc:sldMk cId="1539186271" sldId="256"/>
+            <ac:grpSpMk id="3" creationId="{B17BBE79-F05F-350F-D9D5-782DA549BDEC}"/>
+          </ac:grpSpMkLst>
+        </pc:grpChg>
+        <pc:picChg chg="add mod modCrop">
+          <ac:chgData name="Berkhout, J. (Joost)" userId="86ece86d-8a1a-449b-aae1-5a9ecac02076" providerId="ADAL" clId="{364D4078-C4D2-4C25-A20E-109728476AA8}" dt="2026-09-22T10:36:45.680" v="10" actId="732"/>
+          <ac:picMkLst>
+            <pc:docMk/>
+            <pc:sldMk cId="1539186271" sldId="256"/>
+            <ac:picMk id="9" creationId="{3D5FE2BF-E437-2A0D-3BA1-E9604A617A5E}"/>
+          </ac:picMkLst>
+        </pc:picChg>
+      </pc:sldChg>
+    </pc:docChg>
+  </pc:docChgLst>
+</pc:chgInfo>
 </file>
 
 <file path=ppt/slideLayouts/slideLayout1.xml><?xml version="1.0" encoding="utf-8"?>
@@ -3342,97 +3432,149 @@
           <a:chExt cx="0" cy="0"/>
         </a:xfrm>
       </p:grpSpPr>
-      <p:sp>
-        <p:nvSpPr>
-          <p:cNvPr id="4" name="Oval 3">
-            <a:extLst>
-              <a:ext uri="{FF2B5EF4-FFF2-40B4-BE49-F238E27FC236}">
-                <a16:creationId xmlns:a16="http://schemas.microsoft.com/office/drawing/2014/main" id="{D428F276-84A1-56B2-F399-873494756128}"/>
-              </a:ext>
-            </a:extLst>
-          </p:cNvPr>
-          <p:cNvSpPr/>
+      <p:grpSp>
+        <p:nvGrpSpPr>
+          <p:cNvPr id="2" name="Group 1">
+            <a:extLst>
+              <a:ext uri="{FF2B5EF4-FFF2-40B4-BE49-F238E27FC236}">
+                <a16:creationId xmlns:a16="http://schemas.microsoft.com/office/drawing/2014/main" id="{B4F32D37-7D30-B3DC-D73D-5B1A400FB610}"/>
+              </a:ext>
+            </a:extLst>
+          </p:cNvPr>
+          <p:cNvGrpSpPr/>
           <p:nvPr/>
-        </p:nvSpPr>
+        </p:nvGrpSpPr>
+        <p:grpSpPr>
+          <a:xfrm>
+            <a:off x="4349166" y="2319460"/>
+            <a:ext cx="1891614" cy="2554545"/>
+            <a:chOff x="4349166" y="2319460"/>
+            <a:chExt cx="1891614" cy="2554545"/>
+          </a:xfrm>
+        </p:grpSpPr>
+        <p:sp>
+          <p:nvSpPr>
+            <p:cNvPr id="4" name="Oval 3">
+              <a:extLst>
+                <a:ext uri="{FF2B5EF4-FFF2-40B4-BE49-F238E27FC236}">
+                  <a16:creationId xmlns:a16="http://schemas.microsoft.com/office/drawing/2014/main" id="{D428F276-84A1-56B2-F399-873494756128}"/>
+                </a:ext>
+              </a:extLst>
+            </p:cNvPr>
+            <p:cNvSpPr/>
+            <p:nvPr/>
+          </p:nvSpPr>
+          <p:spPr>
+            <a:xfrm>
+              <a:off x="4349166" y="2650925"/>
+              <a:ext cx="1891614" cy="1891614"/>
+            </a:xfrm>
+            <a:prstGeom prst="ellipse">
+              <a:avLst/>
+            </a:prstGeom>
+            <a:solidFill>
+              <a:schemeClr val="accent3"/>
+            </a:solidFill>
+            <a:ln w="196850">
+              <a:solidFill>
+                <a:schemeClr val="tx1"/>
+              </a:solidFill>
+            </a:ln>
+          </p:spPr>
+          <p:style>
+            <a:lnRef idx="2">
+              <a:schemeClr val="accent1">
+                <a:shade val="15000"/>
+              </a:schemeClr>
+            </a:lnRef>
+            <a:fillRef idx="1">
+              <a:schemeClr val="accent1"/>
+            </a:fillRef>
+            <a:effectRef idx="0">
+              <a:schemeClr val="accent1"/>
+            </a:effectRef>
+            <a:fontRef idx="minor">
+              <a:schemeClr val="lt1"/>
+            </a:fontRef>
+          </p:style>
+          <p:txBody>
+            <a:bodyPr rtlCol="0" anchor="ctr"/>
+            <a:lstStyle/>
+            <a:p>
+              <a:pPr algn="ctr"/>
+              <a:endParaRPr lang="en-NL"/>
+            </a:p>
+          </p:txBody>
+        </p:sp>
+        <p:sp>
+          <p:nvSpPr>
+            <p:cNvPr id="5" name="TextBox 4">
+              <a:extLst>
+                <a:ext uri="{FF2B5EF4-FFF2-40B4-BE49-F238E27FC236}">
+                  <a16:creationId xmlns:a16="http://schemas.microsoft.com/office/drawing/2014/main" id="{B07CC5FF-DB59-C597-4D3C-F706E69D25DA}"/>
+                </a:ext>
+              </a:extLst>
+            </p:cNvPr>
+            <p:cNvSpPr txBox="1"/>
+            <p:nvPr/>
+          </p:nvSpPr>
+          <p:spPr>
+            <a:xfrm>
+              <a:off x="4692244" y="2319460"/>
+              <a:ext cx="1205458" cy="2554545"/>
+            </a:xfrm>
+            <a:prstGeom prst="rect">
+              <a:avLst/>
+            </a:prstGeom>
+            <a:noFill/>
+          </p:spPr>
+          <p:txBody>
+            <a:bodyPr wrap="none" lIns="0" tIns="0" rIns="0" bIns="0" rtlCol="0" anchor="ctr" anchorCtr="0">
+              <a:noAutofit/>
+            </a:bodyPr>
+            <a:lstStyle/>
+            <a:p>
+              <a:pPr algn="ctr"/>
+              <a:r>
+                <a:rPr lang="en-US" sz="16600" dirty="0"/>
+                <a:t>S</a:t>
+              </a:r>
+              <a:endParaRPr lang="en-NL" sz="16600" dirty="0"/>
+            </a:p>
+          </p:txBody>
+        </p:sp>
+      </p:grpSp>
+      <p:pic>
+        <p:nvPicPr>
+          <p:cNvPr id="9" name="Picture 8">
+            <a:extLst>
+              <a:ext uri="{FF2B5EF4-FFF2-40B4-BE49-F238E27FC236}">
+                <a16:creationId xmlns:a16="http://schemas.microsoft.com/office/drawing/2014/main" id="{3D5FE2BF-E437-2A0D-3BA1-E9604A617A5E}"/>
+              </a:ext>
+            </a:extLst>
+          </p:cNvPr>
+          <p:cNvPicPr>
+            <a:picLocks noChangeAspect="1"/>
+          </p:cNvPicPr>
+          <p:nvPr/>
+        </p:nvPicPr>
+        <p:blipFill>
+          <a:blip r:embed="rId2"/>
+          <a:srcRect l="21748" t="18954" r="21748" b="33403"/>
+          <a:stretch>
+            <a:fillRect/>
+          </a:stretch>
+        </p:blipFill>
         <p:spPr>
           <a:xfrm>
-            <a:off x="4349166" y="2650925"/>
-            <a:ext cx="1891614" cy="1891614"/>
-          </a:xfrm>
-          <a:prstGeom prst="ellipse">
-            <a:avLst/>
-          </a:prstGeom>
-          <a:solidFill>
-            <a:schemeClr val="accent3"/>
-          </a:solidFill>
-          <a:ln w="196850">
-            <a:solidFill>
-              <a:schemeClr val="tx1"/>
-            </a:solidFill>
-          </a:ln>
-        </p:spPr>
-        <p:style>
-          <a:lnRef idx="2">
-            <a:schemeClr val="accent1">
-              <a:shade val="15000"/>
-            </a:schemeClr>
-          </a:lnRef>
-          <a:fillRef idx="1">
-            <a:schemeClr val="accent1"/>
-          </a:fillRef>
-          <a:effectRef idx="0">
-            <a:schemeClr val="accent1"/>
-          </a:effectRef>
-          <a:fontRef idx="minor">
-            <a:schemeClr val="lt1"/>
-          </a:fontRef>
-        </p:style>
-        <p:txBody>
-          <a:bodyPr rtlCol="0" anchor="ctr"/>
-          <a:lstStyle/>
-          <a:p>
-            <a:pPr algn="ctr"/>
-            <a:endParaRPr lang="en-NL"/>
-          </a:p>
-        </p:txBody>
-      </p:sp>
-      <p:sp>
-        <p:nvSpPr>
-          <p:cNvPr id="5" name="TextBox 4">
-            <a:extLst>
-              <a:ext uri="{FF2B5EF4-FFF2-40B4-BE49-F238E27FC236}">
-                <a16:creationId xmlns:a16="http://schemas.microsoft.com/office/drawing/2014/main" id="{B07CC5FF-DB59-C597-4D3C-F706E69D25DA}"/>
-              </a:ext>
-            </a:extLst>
-          </p:cNvPr>
-          <p:cNvSpPr txBox="1"/>
-          <p:nvPr/>
-        </p:nvSpPr>
-        <p:spPr>
-          <a:xfrm>
-            <a:off x="4692244" y="2319460"/>
-            <a:ext cx="1205458" cy="2554545"/>
+            <a:off x="6838949" y="2362200"/>
+            <a:ext cx="2108201" cy="2114550"/>
           </a:xfrm>
           <a:prstGeom prst="rect">
             <a:avLst/>
           </a:prstGeom>
-          <a:noFill/>
         </p:spPr>
-        <p:txBody>
-          <a:bodyPr wrap="none" lIns="0" tIns="0" rIns="0" bIns="0" rtlCol="0" anchor="ctr" anchorCtr="0">
-            <a:noAutofit/>
-          </a:bodyPr>
-          <a:lstStyle/>
-          <a:p>
-            <a:pPr algn="ctr"/>
-            <a:r>
-              <a:rPr lang="en-US" sz="16600" dirty="0"/>
-              <a:t>S</a:t>
-            </a:r>
-            <a:endParaRPr lang="en-NL" sz="16600" dirty="0"/>
-          </a:p>
-        </p:txBody>
-      </p:sp>
+      </p:pic>
     </p:spTree>
     <p:extLst>
       <p:ext uri="{BB962C8B-B14F-4D97-AF65-F5344CB8AC3E}">

</xml_diff>